<commit_message>
Tighten claims in the slides and README after a check against the notebook
Correct the training set size (15,752, with 3,939 held out), hedge the
duplicate-posting explanation, and drop claims the notebook does not
support.

Co-Authored-By: Claude Opus 5.5 <noreply@anthropic.com>
Claude-Session: https://claude.ai/code/session_01FweA52RNaUuQsaYrfNv198
</commit_message>
<xml_diff>
--- a/Project 5 Presentation.pptx
+++ b/Project 5 Presentation.pptx
@@ -2872,7 +2872,7 @@
           <a:spcPct val="20000"/>
         </a:spcBef>
         <a:buFont typeface="Arial"/>
-        <a:buChar char="–"/>
+        <a:buChar char="•"/>
         <a:defRPr sz="2800" kern="1200">
           <a:solidFill>
             <a:schemeClr val="tx1"/>
@@ -2902,7 +2902,7 @@
           <a:spcPct val="20000"/>
         </a:spcBef>
         <a:buFont typeface="Arial"/>
-        <a:buChar char="–"/>
+        <a:buChar char="•"/>
         <a:defRPr sz="2000" kern="1200">
           <a:solidFill>
             <a:schemeClr val="tx1"/>
@@ -3666,7 +3666,7 @@
                 </a:solidFill>
                 <a:latin typeface="Calibri"/>
               </a:rPr>
-              <a:t>Scrape new postings; these are from 2021.</a:t>
+              <a:t>Scrape new postings; these were collected for the 2021 project.</a:t>
             </a:r>
           </a:p>
         </p:txBody>
@@ -4995,7 +4995,7 @@
                 </a:solidFill>
                 <a:latin typeface="Calibri"/>
               </a:rPr>
-              <a:t>Lowercased, removed punctuation, reduced words to their base form</a:t>
+              <a:t>Lowercased, removed standalone punctuation, reduced words to their base form</a:t>
             </a:r>
           </a:p>
           <a:p>
@@ -5188,7 +5188,7 @@
                 </a:solidFill>
                 <a:latin typeface="Calibri"/>
               </a:rPr>
-              <a:t>Same cleanup, plus removing title words (data, scientist, engineer and the 150 labels) so the model couldn’t read the title back out of the text</a:t>
+              <a:t>Same cleanup, plus removing title words (data, scientist, engineer and the 150 labels) to make it harder for the model to read the title back out of the text</a:t>
             </a:r>
           </a:p>
           <a:p>
@@ -5503,7 +5503,7 @@
                 </a:solidFill>
                 <a:latin typeface="Calibri"/>
               </a:rPr>
-              <a:t>Some titles come from one employer posting the same job many times, like the acoustic signal processing title with 230 postings.</a:t>
+              <a:t>Some titles seem to come from one employer posting the same job many times, like the acoustic signal processing title with 230 postings.</a:t>
             </a:r>
           </a:p>
         </p:txBody>
@@ -5758,7 +5758,7 @@
                 </a:solidFill>
                 <a:latin typeface="Calibri"/>
               </a:rPr>
-              <a:t>One LinearSVC yes or no classifier per title (one-vs-rest), trained on the descriptions of the 19,691 postings.</a:t>
+              <a:t>One LinearSVC yes or no classifier per title (one-vs-rest), trained on the descriptions of 15,752 of the 19,691 postings. The other 3,939 were the test set.</a:t>
             </a:r>
           </a:p>
           <a:p>
@@ -6450,7 +6450,7 @@
                 </a:solidFill>
                 <a:latin typeface="Calibri"/>
               </a:rPr>
-              <a:t>Test set: 3,939 postings. Precision and recall were added in 2026, from the notebook’s per-title confusion matrices.</a:t>
+              <a:t>Precision and recall were added in 2026, from the notebook’s per-title confusion matrices.</a:t>
             </a:r>
           </a:p>
         </p:txBody>
@@ -8386,7 +8386,49 @@
       </p:graphicFrame>
       <p:sp>
         <p:nvSpPr>
-          <p:cNvPr id="7" name="Rectangle 6"/>
+          <p:cNvPr id="7" name="TextBox 6"/>
+          <p:cNvSpPr txBox="1"/>
+          <p:nvPr/>
+        </p:nvSpPr>
+        <p:spPr>
+          <a:xfrm>
+            <a:off x="548640" y="5669280"/>
+            <a:ext cx="6858000" cy="548640"/>
+          </a:xfrm>
+          <a:prstGeom prst="rect">
+            <a:avLst/>
+          </a:prstGeom>
+          <a:noFill/>
+        </p:spPr>
+        <p:txBody>
+          <a:bodyPr wrap="square" lIns="18288" rIns="18288" tIns="18288" bIns="18288" anchor="t">
+            <a:spAutoFit/>
+          </a:bodyPr>
+          <a:lstStyle/>
+          <a:p>
+            <a:pPr algn="l">
+              <a:lnSpc>
+                <a:spcPct val="110000"/>
+              </a:lnSpc>
+              <a:spcAft>
+                <a:spcPts val="0"/>
+              </a:spcAft>
+            </a:pPr>
+            <a:r>
+              <a:rPr sz="1200" b="0" i="0">
+                <a:solidFill>
+                  <a:srgbClr val="5F636B"/>
+                </a:solidFill>
+                <a:latin typeface="Calibri"/>
+              </a:rPr>
+              <a:t>General titles with 30 or more test postings. Three titles of that size that look like single-employer postings are left out; all three were predicted perfectly.</a:t>
+            </a:r>
+          </a:p>
+        </p:txBody>
+      </p:sp>
+      <p:sp>
+        <p:nvSpPr>
+          <p:cNvPr id="8" name="Rectangle 7"/>
           <p:cNvSpPr/>
           <p:nvPr/>
         </p:nvSpPr>
@@ -8413,7 +8455,7 @@
       </p:sp>
       <p:sp>
         <p:nvSpPr>
-          <p:cNvPr id="8" name="TextBox 7"/>
+          <p:cNvPr id="9" name="TextBox 8"/>
           <p:cNvSpPr txBox="1"/>
           <p:nvPr/>
         </p:nvSpPr>
@@ -8448,7 +8490,7 @@
                 </a:solidFill>
                 <a:latin typeface="Calibri"/>
               </a:rPr>
-              <a:t>94 of the 150 titles were predicted perfectly. Many of them are titles used by a single employer, whose postings repeat the same text and company name.</a:t>
+              <a:t>94 of the 150 titles were predicted perfectly. For many of them the strongest words are a company or place name (ssc, amazon, allstate, harrisburg), which suggests one employer posting the same job many times.</a:t>
             </a:r>
           </a:p>
           <a:p>
@@ -8467,7 +8509,7 @@
                 </a:solidFill>
                 <a:latin typeface="Calibri"/>
               </a:rPr>
-              <a:t>Copies of those postings were probably in both the training and test sets, so the overall score is likely higher than it would be on new postings.</a:t>
+              <a:t>If copies of the same posting ended up in both the training and test sets, the overall score is higher than it would be on new postings.</a:t>
             </a:r>
           </a:p>
           <a:p>
@@ -8486,7 +8528,7 @@
                 </a:solidFill>
                 <a:latin typeface="Calibri"/>
               </a:rPr>
-              <a:t>The common titles are a fairer test: data scientist 93% recall, data analyst 72%, machine learning engineer 66%.</a:t>
+              <a:t>The general titles are a fairer test: data scientist 93% recall, data analyst 72%, machine learning engineer 66%.</a:t>
             </a:r>
           </a:p>
         </p:txBody>
@@ -10827,7 +10869,7 @@
                 </a:solidFill>
                 <a:latin typeface="Calibri"/>
               </a:rPr>
-              <a:t>MiniBatchKMeans on the same descriptions. The error kept falling as clusters were added, with no clear bend, so I used 18, the same as the topic model. Most postings fall in one large group in the plots.</a:t>
+              <a:t>MiniBatchKMeans on the same descriptions. The error kept falling as clusters were added, with no clear bend. I used 18 clusters, the same number as the topic model. Most postings fall in one large group in the plots.</a:t>
             </a:r>
           </a:p>
           <a:p>
@@ -10846,7 +10888,7 @@
                 </a:solidFill>
                 <a:latin typeface="Calibri"/>
               </a:rPr>
-              <a:t>The clusters looked like the topics: single employers (Amazon, Intuit, Facebook) and fields such as university research, clinical trials and agriculture. Charts from the 2021 notebook.</a:t>
+              <a:t>Some clusters were mostly one employer (Amazon, Intuit). Others matched fields such as university research, clinical trials and agriculture. Charts from the 2021 notebook.</a:t>
             </a:r>
           </a:p>
         </p:txBody>

</xml_diff>

<commit_message>
Slides: simpler goal slide; keep C = 100 on one line
Co-Authored-By: Claude Opus 5.5 <noreply@anthropic.com>
Claude-Session: https://claude.ai/code/session_01FweA52RNaUuQsaYrfNv198
</commit_message>
<xml_diff>
--- a/Project 5 Presentation.pptx
+++ b/Project 5 Presentation.pptx
@@ -3879,7 +3879,7 @@
                 </a:solidFill>
                 <a:latin typeface="Calibri"/>
               </a:rPr>
-              <a:t>Use job postings to see which skills data jobs ask for, and how the job titles differ.</a:t>
+              <a:t>Use job postings to show job seekers which skills data jobs ask for and how the job titles differ.</a:t>
             </a:r>
           </a:p>
         </p:txBody>
@@ -3922,7 +3922,7 @@
                 </a:solidFill>
                 <a:latin typeface="Calibri"/>
               </a:rPr>
-              <a:t>Help job seekers keep up with what employers ask for.</a:t>
+              <a:t>The supervised part predicts a posting’s job title from its description, then looks at the words the model relies on for each title.</a:t>
             </a:r>
           </a:p>
           <a:p>
@@ -3942,47 +3942,7 @@
                 </a:solidFill>
                 <a:latin typeface="Calibri"/>
               </a:rPr>
-              <a:t>Help them understand the differences between job titles.</a:t>
-            </a:r>
-          </a:p>
-          <a:p>
-            <a:pPr marL="256032" indent="-256032">
-              <a:lnSpc>
-                <a:spcPct val="108000"/>
-              </a:lnSpc>
-              <a:spcAft>
-                <a:spcPts val="1200"/>
-              </a:spcAft>
-              <a:buChar char="•"/>
-            </a:pPr>
-            <a:r>
-              <a:rPr sz="1800" b="0" i="0">
-                <a:solidFill>
-                  <a:srgbClr val="222222"/>
-                </a:solidFill>
-                <a:latin typeface="Calibri"/>
-              </a:rPr>
-              <a:t>Supervised part: predict a posting’s job title from its description, then look at the words the model relies on for each title.</a:t>
-            </a:r>
-          </a:p>
-          <a:p>
-            <a:pPr marL="256032" indent="-256032">
-              <a:lnSpc>
-                <a:spcPct val="108000"/>
-              </a:lnSpc>
-              <a:spcAft>
-                <a:spcPts val="1200"/>
-              </a:spcAft>
-              <a:buChar char="•"/>
-            </a:pPr>
-            <a:r>
-              <a:rPr sz="1800" b="0" i="0">
-                <a:solidFill>
-                  <a:srgbClr val="222222"/>
-                </a:solidFill>
-                <a:latin typeface="Calibri"/>
-              </a:rPr>
-              <a:t>Unsupervised part: topic modeling and clustering, to see what groups the postings fall into.</a:t>
+              <a:t>The unsupervised part uses topic modeling and clustering to see what groups the postings fall into.</a:t>
             </a:r>
           </a:p>
         </p:txBody>
@@ -5777,7 +5737,7 @@
                 </a:solidFill>
                 <a:latin typeface="Calibri"/>
               </a:rPr>
-              <a:t>A grid search tried C = 1, 10, 100 and 1,000 with 30-fold cross-validation: 120 fits, 14 minutes. The best value was C = 100.</a:t>
+              <a:t>A grid search tried C = 1, 10, 100 and 1,000 with 30-fold cross-validation, 120 fits in 14 minutes. The best value was C = 100.</a:t>
             </a:r>
           </a:p>
           <a:p>

</xml_diff>